<commit_message>
docs: Unifica ETL y MLOps en arquitectura End-to-End
</commit_message>
<xml_diff>
--- a/entregables/Presentacion_SECORSE_VersionA.pptx
+++ b/entregables/Presentacion_SECORSE_VersionA.pptx
@@ -3523,7 +3523,7 @@
           <a:lstStyle/>
           <a:p>
             <a:r>
-              <a:t>Visión Productiva (Infraestructura y Despliegue)</a:t>
+              <a:t>Arquitectura End-to-End (Ecosistema Azure)</a:t>
             </a:r>
           </a:p>
         </p:txBody>
@@ -3544,31 +3544,31 @@
           <a:lstStyle/>
           <a:p>
             <a:r>
-              <a:t>Escalabilidad dentro del ecosistema Microsoft de SECORSE:</a:t>
+              <a:t>Ciclo de vida completo del dato, desde la ingesta hasta la inferencia:</a:t>
             </a:r>
           </a:p>
           <a:p>
             <a:pPr lvl="1"/>
             <a:r>
-              <a:t>• Repositorio y Versionado: Git y GitHub para control estricto de experimentos.</a:t>
+              <a:t>• Ingesta (Data Engineering): Pipeline automatizado (SQLAlchemy) que consolida datos crudos hacia un Data Warehouse en SQL Server.</a:t>
             </a:r>
           </a:p>
           <a:p>
             <a:pPr lvl="1"/>
             <a:r>
-              <a:t>• MLOps (Azure Machine Learning + MLflow): Orquestación del pipeline, registro de métricas de modelos y control de ciclo de vida del modelo.</a:t>
+              <a:t>• Orquestación (MLOps): Azure ML se alimenta de Vistas Analíticas de SQL, controlando el entrenamiento y versionado con MLflow.</a:t>
             </a:r>
           </a:p>
           <a:p>
             <a:pPr lvl="1"/>
             <a:r>
-              <a:t>• Contenedores (Docker): Estandarización de ambientes, listo para despliegue en Azure Container Instances (ACI) o AKS como un servicio REST API (FastAPI) para ingestar nuevas zonas.</a:t>
+              <a:t>• Despliegue (Model Serving): El modelo se contenedoriza en Docker y se expone vía FastAPI para integraciones y tableros de Power BI.</a:t>
             </a:r>
           </a:p>
           <a:p>
             <a:pPr lvl="1"/>
             <a:r>
-              <a:t>• Consumo y Visualización: Modelos expuestos nativamente hacia Power BI mediante conectores de Azure para consumo de la dirección.</a:t>
+              <a:t>• Resiliencia Operativa: Mecanismo 'Fallback'; si la BDD presenta intermitencia, el sistema procesa en memoria local sin detenerse.</a:t>
             </a:r>
           </a:p>
         </p:txBody>

</xml_diff>